<commit_message>
Unit 8: 4.2 GROW question asks how GROW was used in the conversation
</commit_message>
<xml_diff>
--- a/Unit decks/Unit 08 - Performance Measurement.pptx
+++ b/Unit decks/Unit 08 - Performance Measurement.pptx
@@ -1932,7 +1932,7 @@
           <a:p>
             <a:r>
               <a:rPr lang="en-GB" dirty="0"/>
-              <a:t>After class, participants complete personal Portfolio work in part 4.2 of their own file. They read a scripted conversation on a different case, in which the root cause is never named. They deduce which of the three root causes is evident and the lines that rule out the other two, write how they would use GROW to resolve it and move the alignment close to 10, and judge how the CXO applied the Accountability Loop against the GROW model.</a:t>
+              <a:t>After class, participants complete personal Portfolio work in part 4.2 of their own file. They read a scripted conversation on a different case, in which the root cause is never named. They deduce which of the three root causes is evident and the lines that rule out the other two, work out how GROW was used to resolve it and move the alignment close to 10, and judge how the CXO applied the Accountability Loop against the GROW model.</a:t>
             </a:r>
           </a:p>
         </p:txBody>
@@ -2133,7 +2133,7 @@
           <a:p>
             <a:r>
               <a:rPr lang="en-GB" dirty="0"/>
-              <a:t>After class, in part 4.2 of their own file, participants deduce the root cause in a scripted conversation, use GROW to plan its resolution, and judge how the CXO applied the Accountability Loop.</a:t>
+              <a:t>After class, in part 4.2 of their own file, participants deduce the root cause in a scripted conversation, work out how GROW was used to resolve it, and judge how the CXO applied the Accountability Loop.</a:t>
             </a:r>
           </a:p>
         </p:txBody>
@@ -3155,7 +3155,7 @@
           <a:p>
             <a:r>
               <a:rPr lang="en-GB" dirty="0"/>
-              <a:t>Say: "In 4.2, you read a full Accountability Loop conversation on a different case from the role play. The conversation never names the root cause: you deduce which of the three it is, write how you would use GROW to resolve it and move the alignment close to 10, and judge how the CXO applied the loop against GROW. This is personal work, and it builds your learning portfolio."</a:t>
+              <a:t>Say: "In 4.2, you read a full Accountability Loop conversation on a different case from the role play. The conversation never names the root cause: you deduce which of the three it is, work out how GROW was used to resolve it and move the alignment close to 10, and judge how the CXO applied the loop against GROW. This is personal work, and it builds your learning portfolio."</a:t>
             </a:r>
           </a:p>
           <a:p>

</xml_diff>